<commit_message>
docs: add Render free tier cold start note to demo callout and pitch deck
</commit_message>
<xml_diff>
--- a/CHIMERA_Pitch_Deck.pptx
+++ b/CHIMERA_Pitch_Deck.pptx
@@ -9428,7 +9428,7 @@
           </a:p>
           <a:p>
             <a:pPr>
-              <a:defRPr sz="1050">
+              <a:defRPr sz="1000">
                 <a:solidFill>
                   <a:srgbClr val="94A3B8"/>
                 </a:solidFill>
@@ -9439,15 +9439,15 @@
             </a:r>
             <a:br/>
             <a:r>
-              <a:t>• Experience dynamic payment links</a:t>
+              <a:t>• Experience dynamic payment links &amp; Hinglish voice AI</a:t>
             </a:r>
             <a:br/>
             <a:r>
-              <a:t>• Test the conversational Hinglish voice recovery agent</a:t>
+              <a:t>• Inspect the decision room and real-time audit ledger</a:t>
             </a:r>
             <a:br/>
             <a:r>
-              <a:t>• Inspect the decision room and real-time audit ledger</a:t>
+              <a:t>• Note: Hosted on Render free tier; allow ~50s for initial wake-up</a:t>
             </a:r>
           </a:p>
         </p:txBody>

</xml_diff>